<commit_message>
Retitle seminar deck and Part IV; set presenter to Miao Zhang
- Title: "Emerging Techniques for Space-Air-Ground Integrated Networks"
  (also in the footer, document metadata and README)
- Part IV: "MADRL and Rate-Splitting Multiple Access for SAGIN"
  (section divider, outline card, kicker, section name, subtitle,
  conclusion card)
- Presenter name on the title and closing slides: Miao Zhang

Co-Authored-By: Claude Opus 5.5 <noreply@anthropic.com>
Claude-Session: https://claude.ai/code/session_01HjNtnoviiwSshVASHxBpdu
</commit_message>
<xml_diff>
--- a/seminar/SAGIN_Optimization_Seminar.pptx
+++ b/seminar/SAGIN_Optimization_Seminar.pptx
@@ -129,13 +129,13 @@
   <p:extLst>
     <p:ext uri="{521415D9-36F7-43E2-AB2F-B90AF26B5E84}">
       <p14:sectionLst xmlns:p14="http://schemas.microsoft.com/office/powerpoint/2010/main">
-        <p14:section name="Opening" id="{b94b575d-fc9d-b67b-f871-e8b4813a227d}">
+        <p14:section name="Opening" id="{edc4116b-1935-8e20-db2b-e589e52d1213}">
           <p14:sldIdLst>
             <p14:sldId id="256"/>
             <p14:sldId id="257"/>
           </p14:sldIdLst>
         </p14:section>
-        <p14:section name="Part I: Introduction" id="{d98334d5-9d3c-0681-721e-a3df12a434bc}">
+        <p14:section name="Part I: Introduction" id="{a8eef2b2-a9af-0b16-45e3-163a46e814b5}">
           <p14:sldIdLst>
             <p14:sldId id="258"/>
             <p14:sldId id="259"/>
@@ -145,7 +145,7 @@
             <p14:sldId id="263"/>
           </p14:sldIdLst>
         </p14:section>
-        <p14:section name="Part II: Polarforming" id="{80943a94-7062-9374-a741-6b9f91af8867}">
+        <p14:section name="Part II: Polarforming" id="{59d0675b-67a8-6a50-a3c5-c0b4412b4c3d}">
           <p14:sldIdLst>
             <p14:sldId id="264"/>
             <p14:sldId id="265"/>
@@ -153,7 +153,7 @@
             <p14:sldId id="267"/>
           </p14:sldIdLst>
         </p14:section>
-        <p14:section name="Part III: Atomic-to-Space" id="{4661169e-dfb5-5eb2-5650-58a59a97e3f9}">
+        <p14:section name="Part III: Atomic-to-Space" id="{4afd4250-85cc-607b-db36-d45484e50b8a}">
           <p14:sldIdLst>
             <p14:sldId id="268"/>
             <p14:sldId id="269"/>
@@ -161,7 +161,7 @@
             <p14:sldId id="271"/>
           </p14:sldIdLst>
         </p14:section>
-        <p14:section name="Part IV: Multi-Agent DRL" id="{182dc083-aa5c-6bfd-b5e4-ed4522e5aada}">
+        <p14:section name="Part IV: MADRL and RSMA" id="{6ce69e25-441f-7b50-f5f4-660d90b91cdb}">
           <p14:sldIdLst>
             <p14:sldId id="272"/>
             <p14:sldId id="273"/>
@@ -169,7 +169,7 @@
             <p14:sldId id="275"/>
           </p14:sldIdLst>
         </p14:section>
-        <p14:section name="Closing" id="{cb40a790-84f3-b99c-391b-790611c368df}">
+        <p14:section name="Closing" id="{f15eb82c-47d0-74cb-6070-25284feb227d}">
           <p14:sldIdLst>
             <p14:sldId id="276"/>
             <p14:sldId id="277"/>
@@ -5100,7 +5100,7 @@
           <a:p>
             <a:r>
               <a:rPr lang="en-US" dirty="0"/>
-              <a:t>Title slide. Replace the presenter name, affiliation and date (they are placeholders). One-sentence hook: SAGIN promises global 6G coverage, but each layer brings its own bottleneck; this talk shows three optimization tools that address them.</a:t>
+              <a:t>Title slide. Replace the affiliation and date (they are placeholders). One-sentence hook: SAGIN promises global 6G coverage, but each layer brings its own bottleneck; this talk presents three emerging techniques that address them, and how to optimize each one.</a:t>
             </a:r>
             <a:endParaRPr lang="en-US" dirty="0"/>
           </a:p>
@@ -5804,7 +5804,7 @@
           <a:p>
             <a:r>
               <a:rPr lang="en-US" dirty="0"/>
-              <a:t>Part IV: multi-agent deep reinforcement learning for a multi-UAV RSMA network with LEO backhaul.</a:t>
+              <a:t>Part IV: multi-agent deep reinforcement learning combined with rate-splitting multiple access, for a multi-UAV network with LEO backhaul.</a:t>
             </a:r>
             <a:endParaRPr lang="en-US" dirty="0"/>
           </a:p>
@@ -7162,7 +7162,7 @@
                   <a:srgbClr val="B85F12"/>
                 </a:solidFill>
               </a:rPr>
-              <a:t>PART IV  ·  MULTI-AGENT DRL FOR SAGIN</a:t>
+              <a:t>PART IV  ·  MADRL AND RATE-SPLITTING MULTIPLE ACCESS FOR SAGIN</a:t>
             </a:r>
             <a:endParaRPr lang="en-US" sz="1200" dirty="0"/>
           </a:p>
@@ -7366,7 +7366,7 @@
                   <a:srgbClr val="5B6880"/>
                 </a:solidFill>
               </a:rPr>
-              <a:t>Optimization Techniques for SAGINs  ·  Seminar</a:t>
+              <a:t>Emerging Techniques for SAGINs  ·  Seminar</a:t>
             </a:r>
             <a:endParaRPr lang="en-US" sz="1000" dirty="0"/>
           </a:p>
@@ -7767,7 +7767,7 @@
                   <a:srgbClr val="5B6880"/>
                 </a:solidFill>
               </a:rPr>
-              <a:t>Optimization Techniques for SAGINs  ·  Seminar</a:t>
+              <a:t>Emerging Techniques for SAGINs  ·  Seminar</a:t>
             </a:r>
             <a:endParaRPr lang="en-US" sz="1000" dirty="0"/>
           </a:p>
@@ -9260,7 +9260,7 @@
                   <a:srgbClr val="5B6880"/>
                 </a:solidFill>
               </a:rPr>
-              <a:t>Optimization Techniques for SAGINs  ·  Seminar</a:t>
+              <a:t>Emerging Techniques for SAGINs  ·  Seminar</a:t>
             </a:r>
             <a:endParaRPr lang="en-US" sz="1000" dirty="0"/>
           </a:p>
@@ -9658,7 +9658,7 @@
                   <a:srgbClr val="5B6880"/>
                 </a:solidFill>
               </a:rPr>
-              <a:t>Optimization Techniques for SAGINs  ·  Seminar</a:t>
+              <a:t>Emerging Techniques for SAGINs  ·  Seminar</a:t>
             </a:r>
             <a:endParaRPr lang="en-US" sz="1000" dirty="0"/>
           </a:p>
@@ -10056,7 +10056,7 @@
                   <a:srgbClr val="5B6880"/>
                 </a:solidFill>
               </a:rPr>
-              <a:t>Optimization Techniques for SAGINs  ·  Seminar</a:t>
+              <a:t>Emerging Techniques for SAGINs  ·  Seminar</a:t>
             </a:r>
             <a:endParaRPr lang="en-US" sz="1000" dirty="0"/>
           </a:p>
@@ -10581,7 +10581,22 @@
                 <a:ea typeface="+mj-lt" pitchFamily="34" charset="-122"/>
                 <a:cs typeface="+mj-lt" pitchFamily="34" charset="-120"/>
               </a:rPr>
-              <a:t>Optimization Techniques for Space-Air-Ground Integrated Networks</a:t>
+              <a:t>Emerging Techniques for</a:t>
+            </a:r>
+            <a:br/>
+            <a:pPr algn="l" indent="0" marL="0">
+              <a:buNone/>
+            </a:pPr>
+            <a:r>
+              <a:rPr lang="en-US" sz="4000" b="1" dirty="0">
+                <a:solidFill>
+                  <a:srgbClr val="FFFFFF"/>
+                </a:solidFill>
+                <a:latin typeface="+mj-lt" pitchFamily="34" charset="0"/>
+                <a:ea typeface="+mj-lt" pitchFamily="34" charset="-122"/>
+                <a:cs typeface="+mj-lt" pitchFamily="34" charset="-120"/>
+              </a:rPr>
+              <a:t>Space-Air-Ground Integrated Networks</a:t>
             </a:r>
             <a:endParaRPr lang="en-US" sz="4000" dirty="0"/>
           </a:p>
@@ -10619,7 +10634,7 @@
                   <a:srgbClr val="A8D8FF"/>
                 </a:solidFill>
               </a:rPr>
-              <a:t>Polarforming  ·  Atomic Quantum Receivers  ·  Multi-Agent Deep Reinforcement Learning</a:t>
+              <a:t>Polarforming  ·  Atomic Quantum Receivers  ·  MADRL and Rate-Splitting Multiple Access</a:t>
             </a:r>
             <a:endParaRPr lang="en-US" sz="1800" dirty="0"/>
           </a:p>
@@ -10657,7 +10672,7 @@
                   <a:srgbClr val="FFFFFF"/>
                 </a:solidFill>
               </a:rPr>
-              <a:t>Presenter Name</a:t>
+              <a:t>Miao Zhang</a:t>
             </a:r>
             <a:endParaRPr lang="en-US" sz="1500" dirty="0"/>
           </a:p>
@@ -16517,7 +16532,7 @@
                 <a:ea typeface="+mj-lt" pitchFamily="34" charset="-122"/>
                 <a:cs typeface="+mj-lt" pitchFamily="34" charset="-120"/>
               </a:rPr>
-              <a:t>Multi-Agent DRL for SAGIN</a:t>
+              <a:t>MADRL and Rate-Splitting Multiple Access for SAGIN</a:t>
             </a:r>
             <a:endParaRPr lang="en-US" sz="3800" dirty="0"/>
           </a:p>
@@ -19865,7 +19880,7 @@
                   <a:srgbClr val="0B1E3F"/>
                 </a:solidFill>
               </a:rPr>
-              <a:t>Multi-Agent DRL for SAGIN</a:t>
+              <a:t>MADRL and Rate-Splitting Multiple Access for SAGIN</a:t>
             </a:r>
             <a:endParaRPr lang="en-US" sz="1800" dirty="0"/>
           </a:p>
@@ -19977,7 +19992,7 @@
                   <a:srgbClr val="B85F12"/>
                 </a:solidFill>
               </a:rPr>
-              <a:t>Can UAVs learn to cooperate?</a:t>
+              <a:t>Can UAVs learn to share spectrum with RSMA?</a:t>
             </a:r>
             <a:endParaRPr lang="en-US" sz="1400" dirty="0"/>
           </a:p>
@@ -21404,7 +21419,7 @@
                   <a:srgbClr val="0B1E3F"/>
                 </a:solidFill>
               </a:rPr>
-              <a:t>Multi-agent DRL</a:t>
+              <a:t>MADRL + RSMA</a:t>
             </a:r>
             <a:endParaRPr lang="en-US" sz="1700" dirty="0"/>
           </a:p>
@@ -21440,7 +21455,7 @@
                   <a:srgbClr val="1B2638"/>
                 </a:solidFill>
               </a:rPr>
-              <a:t>CTDE learning gives scalable, real-time control of multi-UAV SAGINs from local observations only.</a:t>
+              <a:t>CTDE learning steers UAV trajectories and RSMA power and rate splitting in real time, from local observations only.</a:t>
             </a:r>
             <a:endParaRPr lang="en-US" sz="1400" dirty="0"/>
           </a:p>
@@ -22492,7 +22507,7 @@
                   <a:srgbClr val="D6E2F2"/>
                 </a:solidFill>
               </a:rPr>
-              <a:t>Presenter Name  ·  your.email@university.edu</a:t>
+              <a:t>Miao Zhang  ·  your.email@university.edu</a:t>
             </a:r>
             <a:endParaRPr lang="en-US" sz="1800" dirty="0"/>
           </a:p>

</xml_diff>

<commit_message>
Redraw Part IV divider background for MADRL + RSMA
The Part IV divider now shows a shared neural network (centralized
training) linked to three UAV agents. Each UAV sends a wide common
stream and narrow private streams (rate splitting) to its ground
users on the Earth's limb. This replaces the generic network graph.

Co-Authored-By: Claude Opus 5.5 <noreply@anthropic.com>
Claude-Session: https://claude.ai/code/session_01HjNtnoviiwSshVASHxBpdu
</commit_message>
<xml_diff>
--- a/seminar/SAGIN_Optimization_Seminar.pptx
+++ b/seminar/SAGIN_Optimization_Seminar.pptx
@@ -129,13 +129,13 @@
   <p:extLst>
     <p:ext uri="{521415D9-36F7-43E2-AB2F-B90AF26B5E84}">
       <p14:sectionLst xmlns:p14="http://schemas.microsoft.com/office/powerpoint/2010/main">
-        <p14:section name="Opening" id="{edc4116b-1935-8e20-db2b-e589e52d1213}">
+        <p14:section name="Opening" id="{f115ec85-82dc-0104-4051-f373a8a90d38}">
           <p14:sldIdLst>
             <p14:sldId id="256"/>
             <p14:sldId id="257"/>
           </p14:sldIdLst>
         </p14:section>
-        <p14:section name="Part I: Introduction" id="{a8eef2b2-a9af-0b16-45e3-163a46e814b5}">
+        <p14:section name="Part I: Introduction" id="{fd2f1101-ad0a-33aa-8999-a8813b08bf95}">
           <p14:sldIdLst>
             <p14:sldId id="258"/>
             <p14:sldId id="259"/>
@@ -145,7 +145,7 @@
             <p14:sldId id="263"/>
           </p14:sldIdLst>
         </p14:section>
-        <p14:section name="Part II: Polarforming" id="{59d0675b-67a8-6a50-a3c5-c0b4412b4c3d}">
+        <p14:section name="Part II: Polarforming" id="{06e4c1aa-c1fd-9ab9-6200-c5c06ccf36ef}">
           <p14:sldIdLst>
             <p14:sldId id="264"/>
             <p14:sldId id="265"/>
@@ -153,7 +153,7 @@
             <p14:sldId id="267"/>
           </p14:sldIdLst>
         </p14:section>
-        <p14:section name="Part III: Atomic-to-Space" id="{4afd4250-85cc-607b-db36-d45484e50b8a}">
+        <p14:section name="Part III: Atomic-to-Space" id="{4336ca64-6406-63ff-888c-ef50883f8aba}">
           <p14:sldIdLst>
             <p14:sldId id="268"/>
             <p14:sldId id="269"/>
@@ -161,7 +161,7 @@
             <p14:sldId id="271"/>
           </p14:sldIdLst>
         </p14:section>
-        <p14:section name="Part IV: MADRL and RSMA" id="{6ce69e25-441f-7b50-f5f4-660d90b91cdb}">
+        <p14:section name="Part IV: MADRL and RSMA" id="{17f48f2f-4745-bdf4-41eb-0aa262427bb6}">
           <p14:sldIdLst>
             <p14:sldId id="272"/>
             <p14:sldId id="273"/>
@@ -169,7 +169,7 @@
             <p14:sldId id="275"/>
           </p14:sldIdLst>
         </p14:section>
-        <p14:section name="Closing" id="{f15eb82c-47d0-74cb-6070-25284feb227d}">
+        <p14:section name="Closing" id="{e60a81c9-c773-0952-6037-da3c9e48b3c9}">
           <p14:sldIdLst>
             <p14:sldId id="276"/>
             <p14:sldId id="277"/>

</xml_diff>